<commit_message>
lectures: swap cover logo to the wide ECE horizontal form
Replace the stacked (652x509) department logo in slideLayout1 with the
wide horizontal PNG (4729x504, the reference deck 1-3's image2.png) in
1-4, 1-5, 1-6, 1-7, 1-8, 1-9, 2-1, 2-2. Frame geometry copied verbatim
from 1-3's layout (off 2097131,5715964; ext 5091026x542584) so the wide
image renders at its true 9.4:1 aspect. Relationship retargeted to
image2.png; the orphaned image2.jpeg (referenced only by slideLayout1's
rels in every deck) removed. Content-type Defaults for png/jpeg already
present everywhere, so [Content_Types].xml is untouched. All 8 decks
pass tools/pptx_validate.py (0 OPC, 0 schema); slide-1 renders of all
11 decks visually inspected against the reference.

Co-Authored-By: Claude Opus 5 <noreply@anthropic.com>
</commit_message>
<xml_diff>
--- a/course/lectures/act-1-foundations/04-requirements/slides/1-4-RequirementsEngineering.pptx
+++ b/course/lectures/act-1-foundations/04-requirements/slides/1-4-RequirementsEngineering.pptx
@@ -4114,49 +4114,32 @@
       </p:sp>
       <p:pic>
         <p:nvPicPr>
-          <p:cNvPr id="1026" name="Picture 2" descr="Electrical and Computer Engineering Black and Gold Co-Brand Logo">
+          <p:cNvPr id="1026" name="Purdue CoBrand">
             <a:extLst>
               <a:ext uri="{FF2B5EF4-FFF2-40B4-BE49-F238E27FC236}">
-                <a16:creationId xmlns:a16="http://schemas.microsoft.com/office/drawing/2014/main" id="{DA2A365A-4E3B-2A48-8812-990B2A2EE92D}"/>
+                <a16:creationId xmlns:a16="http://schemas.microsoft.com/office/drawing/2014/main" id="{BCBD89D8-43BD-5D41-99C6-91B0B6A51904}"/>
               </a:ext>
             </a:extLst>
           </p:cNvPr>
           <p:cNvPicPr>
-            <a:picLocks noChangeAspect="1" noChangeArrowheads="1"/>
+            <a:picLocks noChangeAspect="1"/>
           </p:cNvPicPr>
           <p:nvPr userDrawn="1"/>
         </p:nvPicPr>
         <p:blipFill>
-          <a:blip r:embed="rId2">
-            <a:extLst>
-              <a:ext uri="{28A0092B-C50C-407E-A947-70E740481C1C}">
-                <a14:useLocalDpi xmlns:a14="http://schemas.microsoft.com/office/drawing/2010/main" val="0"/>
-              </a:ext>
-            </a:extLst>
-          </a:blip>
-          <a:srcRect/>
+          <a:blip r:embed="rId2"/>
           <a:stretch>
             <a:fillRect/>
           </a:stretch>
         </p:blipFill>
-        <p:spPr bwMode="auto">
-          <a:xfrm>
-            <a:off x="3876158" y="5721845"/>
-            <a:ext cx="1264684" cy="999630"/>
+        <p:spPr>
+          <a:xfrm>
+            <a:off x="2097131" y="5715964"/>
+            <a:ext cx="5091026" cy="542584"/>
           </a:xfrm>
           <a:prstGeom prst="rect">
             <a:avLst/>
           </a:prstGeom>
-          <a:noFill/>
-          <a:extLst>
-            <a:ext uri="{909E8E84-426E-40DD-AFC4-6F175D3DCCD1}">
-              <a14:hiddenFill xmlns:a14="http://schemas.microsoft.com/office/drawing/2010/main">
-                <a:solidFill>
-                  <a:srgbClr val="FFFFFF"/>
-                </a:solidFill>
-              </a14:hiddenFill>
-            </a:ext>
-          </a:extLst>
         </p:spPr>
       </p:pic>
     </p:spTree>

</xml_diff>